<commit_message>
Publish AJBA critical revision 2026-07
</commit_message>
<xml_diff>
--- a/docs/figures_en.pptx
+++ b/docs/figures_en.pptx
@@ -3366,8 +3366,8 @@
         </p:blipFill>
         <p:spPr>
           <a:xfrm>
-            <a:off x="1910771" y="822960"/>
-            <a:ext cx="8370152" cy="5029200"/>
+            <a:off x="1503718" y="822960"/>
+            <a:ext cx="9184258" cy="5029200"/>
           </a:xfrm>
           <a:prstGeom prst="rect">
             <a:avLst/>

</xml_diff>

<commit_message>
Publish final AJBA critical revision 2026-07
</commit_message>
<xml_diff>
--- a/docs/figures_en.pptx
+++ b/docs/figures_en.pptx
@@ -3366,8 +3366,8 @@
         </p:blipFill>
         <p:spPr>
           <a:xfrm>
-            <a:off x="1910771" y="822960"/>
-            <a:ext cx="8370152" cy="5029200"/>
+            <a:off x="1503718" y="822960"/>
+            <a:ext cx="9184258" cy="5029200"/>
           </a:xfrm>
           <a:prstGeom prst="rect">
             <a:avLst/>

</xml_diff>